<commit_message>
feat: schema-driven architecture + template decomposition
Single source of truth for all 68 CLI parameters. Adding a new parameter
now requires editing one JSON file and running `npm run codegen`.

- parameter-schema-v2.json drives CLI registration, validation, and docs
- bin/cli.js imports generated options (replaces 68 hand-written calls)
- config-manager.js imports generated validation rules (43 validators)
- templates/code/serve split into 4 server-specific partials
- templates/do/deploy split into 4 deployment-target files
- templates/do/clean split into 4 deployment-target files
- Interactive command generator widget on docs site
- 3-layer CI drift detection (schema → manifest → widget coverage)
- Test suite: parallel execution, env-driven property test iterations
- All tests green: 4,113 passing
</commit_message>
<xml_diff>
--- a/docs/deep-dive-deck.pptx
+++ b/docs/deep-dive-deck.pptx
@@ -8220,7 +8220,20 @@
               </a:defRPr>
             </a:pPr>
             <a:r>
-              <a:t>npx @aws/ml-container-creator</a:t>
+              <a:rPr dirty="0" err="1"/>
+              <a:t>npx</a:t>
+            </a:r>
+            <a:r>
+              <a:rPr dirty="0"/>
+              <a:t> @</a:t>
+            </a:r>
+            <a:r>
+              <a:rPr dirty="0" err="1"/>
+              <a:t>aws</a:t>
+            </a:r>
+            <a:r>
+              <a:rPr dirty="0"/>
+              <a:t>/ml-container-creator</a:t>
             </a:r>
           </a:p>
         </p:txBody>
@@ -8233,7 +8246,7 @@
         </p:nvSpPr>
         <p:spPr>
           <a:xfrm>
-            <a:off x="914400" y="5486400"/>
+            <a:off x="914400" y="5495109"/>
             <a:ext cx="10058400" cy="457200"/>
           </a:xfrm>
           <a:prstGeom prst="rect">
@@ -8256,7 +8269,24 @@
               </a:defRPr>
             </a:pPr>
             <a:r>
-              <a:t>Open Source · Apache 2.0 · github.com/awslabs/ml-container-creator</a:t>
+              <a:rPr dirty="0"/>
+              <a:t>Open Source · Apache 2.0 · </a:t>
+            </a:r>
+            <a:r>
+              <a:rPr dirty="0" err="1"/>
+              <a:t>github.com</a:t>
+            </a:r>
+            <a:r>
+              <a:rPr dirty="0"/>
+              <a:t>/</a:t>
+            </a:r>
+            <a:r>
+              <a:rPr dirty="0" err="1"/>
+              <a:t>awslabs</a:t>
+            </a:r>
+            <a:r>
+              <a:rPr dirty="0"/>
+              <a:t>/ml-container-creator</a:t>
             </a:r>
           </a:p>
         </p:txBody>
@@ -13333,13 +13363,13 @@
             <p:ph idx="1"/>
             <p:extLst>
               <p:ext uri="{D42A27DB-BD31-4B8C-83A1-F6EECF244321}">
-                <p14:modId xmlns:p14="http://schemas.microsoft.com/office/powerpoint/2010/main" val="2397289799"/>
+                <p14:modId xmlns:p14="http://schemas.microsoft.com/office/powerpoint/2010/main" val="2341874776"/>
               </p:ext>
             </p:extLst>
           </p:nvPr>
         </p:nvGraphicFramePr>
         <p:xfrm>
-          <a:off x="457200" y="1600200"/>
+          <a:off x="496676" y="1930706"/>
           <a:ext cx="11198648" cy="3505200"/>
         </p:xfrm>
         <a:graphic>
@@ -14097,7 +14127,24 @@
               </a:defRPr>
             </a:pPr>
             <a:r>
-              <a:t>Since then (v0.3.0 → v0.5.0):</a:t>
+              <a:rPr dirty="0"/>
+              <a:t>Since then (v0.</a:t>
+            </a:r>
+            <a:r>
+              <a:rPr lang="en-US" dirty="0"/>
+              <a:t>1</a:t>
+            </a:r>
+            <a:r>
+              <a:rPr dirty="0"/>
+              <a:t>.0 → v0.</a:t>
+            </a:r>
+            <a:r>
+              <a:rPr lang="en-US" dirty="0"/>
+              <a:t>9</a:t>
+            </a:r>
+            <a:r>
+              <a:rPr dirty="0"/>
+              <a:t>.0):</a:t>
             </a:r>
           </a:p>
         </p:txBody>
@@ -16850,129 +16897,6 @@
           </a:graphicData>
         </a:graphic>
       </p:graphicFrame>
-      <p:sp>
-        <p:nvSpPr>
-          <p:cNvPr id="5" name="TextBox 4"/>
-          <p:cNvSpPr txBox="1"/>
-          <p:nvPr/>
-        </p:nvSpPr>
-        <p:spPr>
-          <a:xfrm>
-            <a:off x="731520" y="3840480"/>
-            <a:ext cx="10058400" cy="365760"/>
-          </a:xfrm>
-          <a:prstGeom prst="rect">
-            <a:avLst/>
-          </a:prstGeom>
-          <a:noFill/>
-        </p:spPr>
-        <p:txBody>
-          <a:bodyPr wrap="square">
-            <a:spAutoFit/>
-          </a:bodyPr>
-          <a:lstStyle/>
-          <a:p>
-            <a:pPr algn="l">
-              <a:defRPr sz="1800" b="1">
-                <a:solidFill>
-                  <a:srgbClr val="232F3E"/>
-                </a:solidFill>
-                <a:latin typeface="Calibri"/>
-              </a:defRPr>
-            </a:pPr>
-            <a:r>
-              <a:t>Immediate asks:</a:t>
-            </a:r>
-          </a:p>
-        </p:txBody>
-      </p:sp>
-      <p:sp>
-        <p:nvSpPr>
-          <p:cNvPr id="6" name="TextBox 5"/>
-          <p:cNvSpPr txBox="1"/>
-          <p:nvPr/>
-        </p:nvSpPr>
-        <p:spPr>
-          <a:xfrm>
-            <a:off x="731520" y="4297680"/>
-            <a:ext cx="10058400" cy="2286000"/>
-          </a:xfrm>
-          <a:prstGeom prst="rect">
-            <a:avLst/>
-          </a:prstGeom>
-          <a:noFill/>
-        </p:spPr>
-        <p:txBody>
-          <a:bodyPr wrap="square">
-            <a:spAutoFit/>
-          </a:bodyPr>
-          <a:lstStyle/>
-          <a:p>
-            <a:pPr>
-              <a:spcAft>
-                <a:spcPts val="600"/>
-              </a:spcAft>
-              <a:defRPr sz="1500">
-                <a:solidFill>
-                  <a:srgbClr val="232F3E"/>
-                </a:solidFill>
-                <a:latin typeface="Calibri"/>
-              </a:defRPr>
-            </a:pPr>
-            <a:r>
-              <a:t>1.  IC log routing fix — who owns this? Can we get a ticket?</a:t>
-            </a:r>
-          </a:p>
-          <a:p>
-            <a:pPr>
-              <a:spcAft>
-                <a:spcPts val="600"/>
-              </a:spcAft>
-              <a:defRPr sz="1500">
-                <a:solidFill>
-                  <a:srgbClr val="232F3E"/>
-                </a:solidFill>
-                <a:latin typeface="Calibri"/>
-              </a:defRPr>
-            </a:pPr>
-            <a:r>
-              <a:t>2.  RoutingConfig documentation — it's required but undocumented</a:t>
-            </a:r>
-          </a:p>
-          <a:p>
-            <a:pPr>
-              <a:spcAft>
-                <a:spcPts val="600"/>
-              </a:spcAft>
-              <a:defRPr sz="1500">
-                <a:solidFill>
-                  <a:srgbClr val="232F3E"/>
-                </a:solidFill>
-                <a:latin typeface="Calibri"/>
-              </a:defRPr>
-            </a:pPr>
-            <a:r>
-              <a:t>3.  re:Invent 2026 session submission — workshop or builder session</a:t>
-            </a:r>
-          </a:p>
-          <a:p>
-            <a:pPr>
-              <a:spcAft>
-                <a:spcPts val="600"/>
-              </a:spcAft>
-              <a:defRPr sz="1500">
-                <a:solidFill>
-                  <a:srgbClr val="232F3E"/>
-                </a:solidFill>
-                <a:latin typeface="Calibri"/>
-              </a:defRPr>
-            </a:pPr>
-            <a:r>
-              <a:t>4.  Beta customers — who has a customer deploying BYOC this quarter?</a:t>
-            </a:r>
-          </a:p>
-        </p:txBody>
-      </p:sp>
     </p:spTree>
   </p:cSld>
   <p:clrMapOvr>
@@ -19223,7 +19147,7 @@
         <p:spPr>
           <a:xfrm>
             <a:off x="731520" y="2194560"/>
-            <a:ext cx="4572000" cy="1828800"/>
+            <a:ext cx="4572000" cy="1308050"/>
           </a:xfrm>
           <a:prstGeom prst="rect">
             <a:avLst/>
@@ -19248,6 +19172,7 @@
               </a:defRPr>
             </a:pPr>
             <a:r>
+              <a:rPr sz="1600" dirty="0"/>
               <a:t>•  Model name</a:t>
             </a:r>
           </a:p>
@@ -19264,7 +19189,24 @@
               </a:defRPr>
             </a:pPr>
             <a:r>
-              <a:t>•  Serving backend (vLLM, SGLang, Triton, ...)</a:t>
+              <a:rPr sz="1600" dirty="0"/>
+              <a:t>•  Serving backend (</a:t>
+            </a:r>
+            <a:r>
+              <a:rPr sz="1600" dirty="0" err="1"/>
+              <a:t>vLLM</a:t>
+            </a:r>
+            <a:r>
+              <a:rPr sz="1600" dirty="0"/>
+              <a:t>, </a:t>
+            </a:r>
+            <a:r>
+              <a:rPr sz="1600" dirty="0" err="1"/>
+              <a:t>SGLang</a:t>
+            </a:r>
+            <a:r>
+              <a:rPr sz="1600" dirty="0"/>
+              <a:t>, Triton, ...)</a:t>
             </a:r>
           </a:p>
           <a:p>
@@ -19280,6 +19222,7 @@
               </a:defRPr>
             </a:pPr>
             <a:r>
+              <a:rPr sz="1600" dirty="0"/>
               <a:t>•  Instance type</a:t>
             </a:r>
           </a:p>
@@ -19296,6 +19239,7 @@
               </a:defRPr>
             </a:pPr>
             <a:r>
+              <a:rPr sz="1600" dirty="0"/>
               <a:t>•  Deployment target</a:t>
             </a:r>
           </a:p>
@@ -19346,7 +19290,7 @@
         <p:spPr>
           <a:xfrm>
             <a:off x="6400800" y="2194560"/>
-            <a:ext cx="5029200" cy="1828800"/>
+            <a:ext cx="5029200" cy="1308050"/>
           </a:xfrm>
           <a:prstGeom prst="rect">
             <a:avLst/>
@@ -19371,7 +19315,16 @@
               </a:defRPr>
             </a:pPr>
             <a:r>
-              <a:t>•  Dockerfile (multi-stage, optimized)</a:t>
+              <a:rPr sz="1600" dirty="0"/>
+              <a:t>•  </a:t>
+            </a:r>
+            <a:r>
+              <a:rPr sz="1600" dirty="0" err="1"/>
+              <a:t>Dockerfile</a:t>
+            </a:r>
+            <a:r>
+              <a:rPr sz="1600" dirty="0"/>
+              <a:t> (multi-stage, optimized)</a:t>
             </a:r>
           </a:p>
           <a:p>
@@ -19387,7 +19340,16 @@
               </a:defRPr>
             </a:pPr>
             <a:r>
-              <a:t>•  code/serve (entrypoint script)</a:t>
+              <a:rPr sz="1600" dirty="0"/>
+              <a:t>•  code/serve (</a:t>
+            </a:r>
+            <a:r>
+              <a:rPr sz="1600" dirty="0" err="1"/>
+              <a:t>entrypoint</a:t>
+            </a:r>
+            <a:r>
+              <a:rPr sz="1600" dirty="0"/>
+              <a:t> script)</a:t>
             </a:r>
           </a:p>
           <a:p>
@@ -19403,6 +19365,7 @@
               </a:defRPr>
             </a:pPr>
             <a:r>
+              <a:rPr sz="1600" dirty="0"/>
               <a:t>•  do/ lifecycle scripts (20+)</a:t>
             </a:r>
           </a:p>
@@ -19419,8 +19382,14 @@
               </a:defRPr>
             </a:pPr>
             <a:r>
-              <a:t>•  Tests, IAM docs, README</a:t>
-            </a:r>
+              <a:rPr sz="1600" dirty="0"/>
+              <a:t>•</a:t>
+            </a:r>
+            <a:r>
+              <a:rPr lang="en-US" sz="1600" dirty="0"/>
+              <a:t>  Hooks into long-tail optimizations</a:t>
+            </a:r>
+            <a:endParaRPr sz="1600" dirty="0"/>
           </a:p>
         </p:txBody>
       </p:sp>
@@ -19469,7 +19438,7 @@
         <p:spPr>
           <a:xfrm>
             <a:off x="731520" y="4846320"/>
-            <a:ext cx="10058400" cy="1371600"/>
+            <a:ext cx="10058400" cy="1308050"/>
           </a:xfrm>
           <a:prstGeom prst="rect">
             <a:avLst/>
@@ -19494,7 +19463,16 @@
               </a:defRPr>
             </a:pPr>
             <a:r>
-              <a:t>•  You own the output — no runtime dependency on MCC</a:t>
+              <a:rPr sz="1600" dirty="0"/>
+              <a:t>•  You own the output</a:t>
+            </a:r>
+            <a:r>
+              <a:rPr lang="en-US" sz="1600" dirty="0"/>
+              <a:t>, </a:t>
+            </a:r>
+            <a:r>
+              <a:rPr sz="1600" dirty="0"/>
+              <a:t>no runtime dependency on MCC</a:t>
             </a:r>
           </a:p>
           <a:p>
@@ -19510,7 +19488,12 @@
               </a:defRPr>
             </a:pPr>
             <a:r>
-              <a:t>•  No agent in your container, no lock-in</a:t>
+              <a:rPr sz="1600" dirty="0"/>
+              <a:t>•  No agent in your container</a:t>
+            </a:r>
+            <a:r>
+              <a:rPr lang="en-US" sz="1600" dirty="0"/>
+              <a:t>, no lock-in</a:t>
             </a:r>
           </a:p>
           <a:p>
@@ -19526,7 +19509,25 @@
               </a:defRPr>
             </a:pPr>
             <a:r>
+              <a:rPr lang="en-US" sz="1600" dirty="0"/>
               <a:t>•  Opinionated defaults, full escape hatches</a:t>
+            </a:r>
+          </a:p>
+          <a:p>
+            <a:pPr>
+              <a:spcAft>
+                <a:spcPts val="600"/>
+              </a:spcAft>
+              <a:defRPr sz="1500">
+                <a:solidFill>
+                  <a:srgbClr val="232F3E"/>
+                </a:solidFill>
+                <a:latin typeface="Calibri"/>
+              </a:defRPr>
+            </a:pPr>
+            <a:r>
+              <a:rPr lang="en-US" sz="1600" dirty="0"/>
+              <a:t>•  Extensible boilerplate, build on the core elements</a:t>
             </a:r>
           </a:p>
         </p:txBody>
@@ -19653,7 +19654,7 @@
         <p:spPr>
           <a:xfrm>
             <a:off x="731520" y="1188720"/>
-            <a:ext cx="10058400" cy="4114800"/>
+            <a:ext cx="10058400" cy="3847207"/>
           </a:xfrm>
           <a:prstGeom prst="rect">
             <a:avLst/>
@@ -19678,7 +19679,8 @@
               </a:defRPr>
             </a:pPr>
             <a:r>
-              <a:t>CLI → Config Manager (8-level precedence) → Template Engine (EJS)</a:t>
+              <a:rPr sz="1600" dirty="0"/>
+              <a:t>CLI → Config Manager → Template Engine (EJS)</a:t>
             </a:r>
           </a:p>
           <a:p>
@@ -19693,7 +19695,7 @@
                 <a:latin typeface="Calibri"/>
               </a:defRPr>
             </a:pPr>
-            <a:endParaRPr/>
+            <a:endParaRPr dirty="0"/>
           </a:p>
           <a:p>
             <a:pPr>
@@ -19708,6 +19710,7 @@
               </a:defRPr>
             </a:pPr>
             <a:r>
+              <a:rPr sz="1600" dirty="0"/>
               <a:t>6 MCP Servers provide intelligent defaults:</a:t>
             </a:r>
           </a:p>
@@ -19724,6 +19727,7 @@
               </a:defRPr>
             </a:pPr>
             <a:r>
+              <a:rPr sz="1600" dirty="0"/>
               <a:t>    instance-sizer, region-picker, base-image-picker,</a:t>
             </a:r>
           </a:p>
@@ -19740,7 +19744,16 @@
               </a:defRPr>
             </a:pPr>
             <a:r>
-              <a:t>    model-picker, hyperpod-cluster-picker, endpoint-picker</a:t>
+              <a:rPr sz="1600" dirty="0"/>
+              <a:t>    model-picker, </a:t>
+            </a:r>
+            <a:r>
+              <a:rPr sz="1600" dirty="0" err="1"/>
+              <a:t>hyperpod</a:t>
+            </a:r>
+            <a:r>
+              <a:rPr sz="1600" dirty="0"/>
+              <a:t>-cluster-picker, endpoint-picker</a:t>
             </a:r>
           </a:p>
           <a:p>
@@ -19755,7 +19768,7 @@
                 <a:latin typeface="Calibri"/>
               </a:defRPr>
             </a:pPr>
-            <a:endParaRPr/>
+            <a:endParaRPr dirty="0"/>
           </a:p>
           <a:p>
             <a:pPr>
@@ -19770,6 +19783,7 @@
               </a:defRPr>
             </a:pPr>
             <a:r>
+              <a:rPr sz="1600" dirty="0"/>
               <a:t>3 Catalogs validate every combination:</a:t>
             </a:r>
           </a:p>
@@ -19786,8 +19800,22 @@
               </a:defRPr>
             </a:pPr>
             <a:r>
-              <a:t>    model-servers.json — 14 server versions, base images, CUDA compat</a:t>
-            </a:r>
+              <a:rPr sz="1600" dirty="0"/>
+              <a:t>    model-</a:t>
+            </a:r>
+            <a:r>
+              <a:rPr sz="1600" dirty="0" err="1"/>
+              <a:t>servers.json</a:t>
+            </a:r>
+            <a:r>
+              <a:rPr sz="1600" dirty="0"/>
+              <a:t> — 14 server versions, base images, CUDA </a:t>
+            </a:r>
+            <a:r>
+              <a:rPr sz="1600" dirty="0" err="1"/>
+              <a:t>compat</a:t>
+            </a:r>
+            <a:endParaRPr sz="1600" dirty="0"/>
           </a:p>
           <a:p>
             <a:pPr>
@@ -19802,7 +19830,16 @@
               </a:defRPr>
             </a:pPr>
             <a:r>
-              <a:t>    models.json — Popular models, parameter counts, recommended instances</a:t>
+              <a:rPr sz="1600" dirty="0"/>
+              <a:t>    </a:t>
+            </a:r>
+            <a:r>
+              <a:rPr sz="1600" dirty="0" err="1"/>
+              <a:t>models.json</a:t>
+            </a:r>
+            <a:r>
+              <a:rPr sz="1600" dirty="0"/>
+              <a:t> — Popular models, parameter counts, recommended instances</a:t>
             </a:r>
           </a:p>
           <a:p>
@@ -19818,7 +19855,16 @@
               </a:defRPr>
             </a:pPr>
             <a:r>
-              <a:t>    instances.json — 48 types, GPU specs, memory, cost tiers</a:t>
+              <a:rPr sz="1600" dirty="0"/>
+              <a:t>    </a:t>
+            </a:r>
+            <a:r>
+              <a:rPr sz="1600" dirty="0" err="1"/>
+              <a:t>instances.json</a:t>
+            </a:r>
+            <a:r>
+              <a:rPr sz="1600" dirty="0"/>
+              <a:t> — 48 types, GPU specs, memory, cost tiers</a:t>
             </a:r>
           </a:p>
           <a:p>
@@ -19833,7 +19879,7 @@
                 <a:latin typeface="Calibri"/>
               </a:defRPr>
             </a:pPr>
-            <a:endParaRPr/>
+            <a:endParaRPr dirty="0"/>
           </a:p>
           <a:p>
             <a:pPr>
@@ -19848,7 +19894,16 @@
               </a:defRPr>
             </a:pPr>
             <a:r>
-              <a:t>Output: Complete project with Dockerfile + code/ + do/ + tests</a:t>
+              <a:rPr sz="1600" dirty="0"/>
+              <a:t>Output: Complete project with </a:t>
+            </a:r>
+            <a:r>
+              <a:rPr sz="1600" dirty="0" err="1"/>
+              <a:t>Dockerfile</a:t>
+            </a:r>
+            <a:r>
+              <a:rPr sz="1600" dirty="0"/>
+              <a:t> + code/ + do/ + tests</a:t>
             </a:r>
           </a:p>
         </p:txBody>
@@ -20008,7 +20063,13 @@
           <p:cNvGraphicFramePr>
             <a:graphicFrameLocks noGrp="1"/>
           </p:cNvGraphicFramePr>
-          <p:nvPr/>
+          <p:nvPr>
+            <p:extLst>
+              <p:ext uri="{D42A27DB-BD31-4B8C-83A1-F6EECF244321}">
+                <p14:modId xmlns:p14="http://schemas.microsoft.com/office/powerpoint/2010/main" val="363291220"/>
+              </p:ext>
+            </p:extLst>
+          </p:nvPr>
         </p:nvGraphicFramePr>
         <p:xfrm>
           <a:off x="731520" y="1463040"/>
@@ -20062,11 +20123,7 @@
                       </a:r>
                     </a:p>
                   </a:txBody>
-                  <a:tcPr>
-                    <a:solidFill>
-                      <a:srgbClr val="232F3E"/>
-                    </a:solidFill>
-                  </a:tcPr>
+                  <a:tcPr/>
                 </a:tc>
                 <a:tc>
                   <a:txBody>
@@ -20086,11 +20143,7 @@
                       </a:r>
                     </a:p>
                   </a:txBody>
-                  <a:tcPr>
-                    <a:solidFill>
-                      <a:srgbClr val="232F3E"/>
-                    </a:solidFill>
-                  </a:tcPr>
+                  <a:tcPr/>
                 </a:tc>
                 <a:tc>
                   <a:txBody>
@@ -20110,11 +20163,7 @@
                       </a:r>
                     </a:p>
                   </a:txBody>
-                  <a:tcPr>
-                    <a:solidFill>
-                      <a:srgbClr val="232F3E"/>
-                    </a:solidFill>
-                  </a:tcPr>
+                  <a:tcPr/>
                 </a:tc>
                 <a:extLst>
                   <a:ext uri="{0D108BD9-81ED-4DB2-BD59-A6C34878D82A}">
@@ -20208,11 +20257,7 @@
                       </a:r>
                     </a:p>
                   </a:txBody>
-                  <a:tcPr>
-                    <a:solidFill>
-                      <a:srgbClr val="F8F8F8"/>
-                    </a:solidFill>
-                  </a:tcPr>
+                  <a:tcPr/>
                 </a:tc>
                 <a:tc>
                   <a:txBody>
@@ -20232,11 +20277,7 @@
                       </a:r>
                     </a:p>
                   </a:txBody>
-                  <a:tcPr>
-                    <a:solidFill>
-                      <a:srgbClr val="F8F8F8"/>
-                    </a:solidFill>
-                  </a:tcPr>
+                  <a:tcPr/>
                 </a:tc>
                 <a:tc>
                   <a:txBody>
@@ -20256,11 +20297,7 @@
                       </a:r>
                     </a:p>
                   </a:txBody>
-                  <a:tcPr>
-                    <a:solidFill>
-                      <a:srgbClr val="F8F8F8"/>
-                    </a:solidFill>
-                  </a:tcPr>
+                  <a:tcPr/>
                 </a:tc>
                 <a:extLst>
                   <a:ext uri="{0D108BD9-81ED-4DB2-BD59-A6C34878D82A}">
@@ -20354,11 +20391,7 @@
                       </a:r>
                     </a:p>
                   </a:txBody>
-                  <a:tcPr>
-                    <a:solidFill>
-                      <a:srgbClr val="F8F8F8"/>
-                    </a:solidFill>
-                  </a:tcPr>
+                  <a:tcPr/>
                 </a:tc>
                 <a:tc>
                   <a:txBody>
@@ -20378,11 +20411,7 @@
                       </a:r>
                     </a:p>
                   </a:txBody>
-                  <a:tcPr>
-                    <a:solidFill>
-                      <a:srgbClr val="F8F8F8"/>
-                    </a:solidFill>
-                  </a:tcPr>
+                  <a:tcPr/>
                 </a:tc>
                 <a:tc>
                   <a:txBody>
@@ -20398,15 +20427,12 @@
                         </a:defRPr>
                       </a:pPr>
                       <a:r>
+                        <a:rPr dirty="0"/>
                         <a:t>Image generation</a:t>
                       </a:r>
                     </a:p>
                   </a:txBody>
-                  <a:tcPr>
-                    <a:solidFill>
-                      <a:srgbClr val="F8F8F8"/>
-                    </a:solidFill>
-                  </a:tcPr>
+                  <a:tcPr/>
                 </a:tc>
                 <a:extLst>
                   <a:ext uri="{0D108BD9-81ED-4DB2-BD59-A6C34878D82A}">
@@ -20424,7 +20450,13 @@
           <p:cNvGraphicFramePr>
             <a:graphicFrameLocks noGrp="1"/>
           </p:cNvGraphicFramePr>
-          <p:nvPr/>
+          <p:nvPr>
+            <p:extLst>
+              <p:ext uri="{D42A27DB-BD31-4B8C-83A1-F6EECF244321}">
+                <p14:modId xmlns:p14="http://schemas.microsoft.com/office/powerpoint/2010/main" val="200017331"/>
+              </p:ext>
+            </p:extLst>
+          </p:nvPr>
         </p:nvGraphicFramePr>
         <p:xfrm>
           <a:off x="731520" y="4206240"/>
@@ -20471,11 +20503,7 @@
                       </a:r>
                     </a:p>
                   </a:txBody>
-                  <a:tcPr>
-                    <a:solidFill>
-                      <a:srgbClr val="232F3E"/>
-                    </a:solidFill>
-                  </a:tcPr>
+                  <a:tcPr/>
                 </a:tc>
                 <a:tc>
                   <a:txBody>
@@ -20495,11 +20523,7 @@
                       </a:r>
                     </a:p>
                   </a:txBody>
-                  <a:tcPr>
-                    <a:solidFill>
-                      <a:srgbClr val="232F3E"/>
-                    </a:solidFill>
-                  </a:tcPr>
+                  <a:tcPr/>
                 </a:tc>
                 <a:extLst>
                   <a:ext uri="{0D108BD9-81ED-4DB2-BD59-A6C34878D82A}">
@@ -20573,11 +20597,7 @@
                       </a:r>
                     </a:p>
                   </a:txBody>
-                  <a:tcPr>
-                    <a:solidFill>
-                      <a:srgbClr val="F8F8F8"/>
-                    </a:solidFill>
-                  </a:tcPr>
+                  <a:tcPr/>
                 </a:tc>
                 <a:tc>
                   <a:txBody>
@@ -20597,11 +20617,7 @@
                       </a:r>
                     </a:p>
                   </a:txBody>
-                  <a:tcPr>
-                    <a:solidFill>
-                      <a:srgbClr val="F8F8F8"/>
-                    </a:solidFill>
-                  </a:tcPr>
+                  <a:tcPr/>
                 </a:tc>
                 <a:extLst>
                   <a:ext uri="{0D108BD9-81ED-4DB2-BD59-A6C34878D82A}">
@@ -20675,11 +20691,7 @@
                       </a:r>
                     </a:p>
                   </a:txBody>
-                  <a:tcPr>
-                    <a:solidFill>
-                      <a:srgbClr val="F8F8F8"/>
-                    </a:solidFill>
-                  </a:tcPr>
+                  <a:tcPr/>
                 </a:tc>
                 <a:tc>
                   <a:txBody>
@@ -20695,15 +20707,12 @@
                         </a:defRPr>
                       </a:pPr>
                       <a:r>
+                        <a:rPr dirty="0"/>
                         <a:t>Kubernetes, GPU scheduling, heterogeneous clusters</a:t>
                       </a:r>
                     </a:p>
                   </a:txBody>
-                  <a:tcPr>
-                    <a:solidFill>
-                      <a:srgbClr val="F8F8F8"/>
-                    </a:solidFill>
-                  </a:tcPr>
+                  <a:tcPr/>
                 </a:tc>
                 <a:extLst>
                   <a:ext uri="{0D108BD9-81ED-4DB2-BD59-A6C34878D82A}">
@@ -20870,7 +20879,13 @@
           <p:cNvGraphicFramePr>
             <a:graphicFrameLocks noGrp="1"/>
           </p:cNvGraphicFramePr>
-          <p:nvPr/>
+          <p:nvPr>
+            <p:extLst>
+              <p:ext uri="{D42A27DB-BD31-4B8C-83A1-F6EECF244321}">
+                <p14:modId xmlns:p14="http://schemas.microsoft.com/office/powerpoint/2010/main" val="1603080608"/>
+              </p:ext>
+            </p:extLst>
+          </p:nvPr>
         </p:nvGraphicFramePr>
         <p:xfrm>
           <a:off x="731520" y="1463040"/>
@@ -20924,11 +20939,7 @@
                       </a:r>
                     </a:p>
                   </a:txBody>
-                  <a:tcPr>
-                    <a:solidFill>
-                      <a:srgbClr val="232F3E"/>
-                    </a:solidFill>
-                  </a:tcPr>
+                  <a:tcPr/>
                 </a:tc>
                 <a:tc>
                   <a:txBody>
@@ -20948,11 +20959,7 @@
                       </a:r>
                     </a:p>
                   </a:txBody>
-                  <a:tcPr>
-                    <a:solidFill>
-                      <a:srgbClr val="232F3E"/>
-                    </a:solidFill>
-                  </a:tcPr>
+                  <a:tcPr/>
                 </a:tc>
                 <a:tc>
                   <a:txBody>
@@ -20972,11 +20979,7 @@
                       </a:r>
                     </a:p>
                   </a:txBody>
-                  <a:tcPr>
-                    <a:solidFill>
-                      <a:srgbClr val="232F3E"/>
-                    </a:solidFill>
-                  </a:tcPr>
+                  <a:tcPr/>
                 </a:tc>
                 <a:extLst>
                   <a:ext uri="{0D108BD9-81ED-4DB2-BD59-A6C34878D82A}">
@@ -20999,6 +21002,7 @@
                         </a:defRPr>
                       </a:pPr>
                       <a:r>
+                        <a:rPr sz="1600" dirty="0"/>
                         <a:t>Build</a:t>
                       </a:r>
                     </a:p>
@@ -21019,6 +21023,7 @@
                         </a:defRPr>
                       </a:pPr>
                       <a:r>
+                        <a:rPr sz="1600"/>
                         <a:t>build, run, push, submit</a:t>
                       </a:r>
                     </a:p>
@@ -21039,6 +21044,7 @@
                         </a:defRPr>
                       </a:pPr>
                       <a:r>
+                        <a:rPr sz="1600"/>
                         <a:t>Container lifecycle</a:t>
                       </a:r>
                     </a:p>
@@ -21066,15 +21072,12 @@
                         </a:defRPr>
                       </a:pPr>
                       <a:r>
+                        <a:rPr sz="1600"/>
                         <a:t>Deploy</a:t>
                       </a:r>
                     </a:p>
                   </a:txBody>
-                  <a:tcPr>
-                    <a:solidFill>
-                      <a:srgbClr val="F8F8F8"/>
-                    </a:solidFill>
-                  </a:tcPr>
+                  <a:tcPr/>
                 </a:tc>
                 <a:tc>
                   <a:txBody>
@@ -21090,15 +21093,20 @@
                         </a:defRPr>
                       </a:pPr>
                       <a:r>
-                        <a:t>deploy, add-ic, status, clean</a:t>
+                        <a:rPr sz="1600" dirty="0"/>
+                        <a:t>deploy, add-</a:t>
+                      </a:r>
+                      <a:r>
+                        <a:rPr sz="1600" dirty="0" err="1"/>
+                        <a:t>ic</a:t>
+                      </a:r>
+                      <a:r>
+                        <a:rPr sz="1600" dirty="0"/>
+                        <a:t>, status, clean</a:t>
                       </a:r>
                     </a:p>
                   </a:txBody>
-                  <a:tcPr>
-                    <a:solidFill>
-                      <a:srgbClr val="F8F8F8"/>
-                    </a:solidFill>
-                  </a:tcPr>
+                  <a:tcPr/>
                 </a:tc>
                 <a:tc>
                   <a:txBody>
@@ -21114,15 +21122,12 @@
                         </a:defRPr>
                       </a:pPr>
                       <a:r>
+                        <a:rPr sz="1600"/>
                         <a:t>SageMaker infrastructure</a:t>
                       </a:r>
                     </a:p>
                   </a:txBody>
-                  <a:tcPr>
-                    <a:solidFill>
-                      <a:srgbClr val="F8F8F8"/>
-                    </a:solidFill>
-                  </a:tcPr>
+                  <a:tcPr/>
                 </a:tc>
                 <a:extLst>
                   <a:ext uri="{0D108BD9-81ED-4DB2-BD59-A6C34878D82A}">
@@ -21145,6 +21150,7 @@
                         </a:defRPr>
                       </a:pPr>
                       <a:r>
+                        <a:rPr sz="1600"/>
                         <a:t>Observe</a:t>
                       </a:r>
                     </a:p>
@@ -21165,6 +21171,7 @@
                         </a:defRPr>
                       </a:pPr>
                       <a:r>
+                        <a:rPr sz="1600" dirty="0"/>
                         <a:t>test, logs, benchmark</a:t>
                       </a:r>
                     </a:p>
@@ -21185,6 +21192,7 @@
                         </a:defRPr>
                       </a:pPr>
                       <a:r>
+                        <a:rPr sz="1600"/>
                         <a:t>Validation &amp; monitoring</a:t>
                       </a:r>
                     </a:p>
@@ -21212,15 +21220,12 @@
                         </a:defRPr>
                       </a:pPr>
                       <a:r>
+                        <a:rPr sz="1600"/>
                         <a:t>Adapt</a:t>
                       </a:r>
                     </a:p>
                   </a:txBody>
-                  <a:tcPr>
-                    <a:solidFill>
-                      <a:srgbClr val="F8F8F8"/>
-                    </a:solidFill>
-                  </a:tcPr>
+                  <a:tcPr/>
                 </a:tc>
                 <a:tc>
                   <a:txBody>
@@ -21236,15 +21241,12 @@
                         </a:defRPr>
                       </a:pPr>
                       <a:r>
+                        <a:rPr sz="1600" dirty="0"/>
                         <a:t>adapter (add/list/remove/update)</a:t>
                       </a:r>
                     </a:p>
                   </a:txBody>
-                  <a:tcPr>
-                    <a:solidFill>
-                      <a:srgbClr val="F8F8F8"/>
-                    </a:solidFill>
-                  </a:tcPr>
+                  <a:tcPr/>
                 </a:tc>
                 <a:tc>
                   <a:txBody>
@@ -21260,15 +21262,12 @@
                         </a:defRPr>
                       </a:pPr>
                       <a:r>
+                        <a:rPr sz="1600"/>
                         <a:t>LoRA hot-swap</a:t>
                       </a:r>
                     </a:p>
                   </a:txBody>
-                  <a:tcPr>
-                    <a:solidFill>
-                      <a:srgbClr val="F8F8F8"/>
-                    </a:solidFill>
-                  </a:tcPr>
+                  <a:tcPr/>
                 </a:tc>
                 <a:extLst>
                   <a:ext uri="{0D108BD9-81ED-4DB2-BD59-A6C34878D82A}">
@@ -21291,6 +21290,7 @@
                         </a:defRPr>
                       </a:pPr>
                       <a:r>
+                        <a:rPr sz="1600"/>
                         <a:t>Operate</a:t>
                       </a:r>
                     </a:p>
@@ -21311,6 +21311,7 @@
                         </a:defRPr>
                       </a:pPr>
                       <a:r>
+                        <a:rPr sz="1600" dirty="0"/>
                         <a:t>register, export, validate, optimize</a:t>
                       </a:r>
                     </a:p>
@@ -21331,6 +21332,7 @@
                         </a:defRPr>
                       </a:pPr>
                       <a:r>
+                        <a:rPr sz="1600" dirty="0"/>
                         <a:t>Day-2 operations</a:t>
                       </a:r>
                     </a:p>
@@ -21358,15 +21360,12 @@
                         </a:defRPr>
                       </a:pPr>
                       <a:r>
+                        <a:rPr sz="1600" dirty="0"/>
                         <a:t>Train</a:t>
                       </a:r>
                     </a:p>
                   </a:txBody>
-                  <a:tcPr>
-                    <a:solidFill>
-                      <a:srgbClr val="F8F8F8"/>
-                    </a:solidFill>
-                  </a:tcPr>
+                  <a:tcPr/>
                 </a:tc>
                 <a:tc>
                   <a:txBody>
@@ -21382,15 +21381,12 @@
                         </a:defRPr>
                       </a:pPr>
                       <a:r>
+                        <a:rPr sz="1600" dirty="0"/>
                         <a:t>tune, train</a:t>
                       </a:r>
                     </a:p>
                   </a:txBody>
-                  <a:tcPr>
-                    <a:solidFill>
-                      <a:srgbClr val="F8F8F8"/>
-                    </a:solidFill>
-                  </a:tcPr>
+                  <a:tcPr/>
                 </a:tc>
                 <a:tc>
                   <a:txBody>
@@ -21406,15 +21402,12 @@
                         </a:defRPr>
                       </a:pPr>
                       <a:r>
+                        <a:rPr sz="1600"/>
                         <a:t>Fine-tuning &amp; bespoke training</a:t>
                       </a:r>
                     </a:p>
                   </a:txBody>
-                  <a:tcPr>
-                    <a:solidFill>
-                      <a:srgbClr val="F8F8F8"/>
-                    </a:solidFill>
-                  </a:tcPr>
+                  <a:tcPr/>
                 </a:tc>
                 <a:extLst>
                   <a:ext uri="{0D108BD9-81ED-4DB2-BD59-A6C34878D82A}">
@@ -21437,6 +21430,7 @@
                         </a:defRPr>
                       </a:pPr>
                       <a:r>
+                        <a:rPr sz="1600"/>
                         <a:t>CI</a:t>
                       </a:r>
                     </a:p>
@@ -21457,6 +21451,7 @@
                         </a:defRPr>
                       </a:pPr>
                       <a:r>
+                        <a:rPr sz="1600"/>
                         <a:t>ci, manifest</a:t>
                       </a:r>
                     </a:p>
@@ -21477,6 +21472,7 @@
                         </a:defRPr>
                       </a:pPr>
                       <a:r>
+                        <a:rPr sz="1600" dirty="0"/>
                         <a:t>Pipeline integration</a:t>
                       </a:r>
                     </a:p>

</xml_diff>